<commit_message>
v17: rebuilt dataset and deck from the release archive
The dataset is regenerated with the MODELLED charge temperature rather than the
pre-throttle sensor, which mistake 13 identifies as a compressor outlet. The
manifold-pressure column moves with it; nothing else in the data changes.

Effect on the pooled operating points: the span moves 31-82 -> 30-74 kPa. The
same 22 points, on a corrected pressure scale.

Co-Authored-By: Claude Opus 5 (1M context) <noreply@anthropic.com>
</commit_message>
<xml_diff>
--- a/Project_Proposal_5.pptx
+++ b/Project_Proposal_5.pptx
@@ -1573,7 +1573,7 @@
           <a:p>
             <a:r>
               <a:rPr lang="en-US" dirty="0"/>
-              <a:t>The two lines overlay because the model reproduces the load trend to 1.4% with NO fitted parameters at all. The normalisation constant k is not tuned: our load is referenced to 100 kPa at the measured intake temperature, BMW's to the DIN state of 1013 mbar and 0 C, and the ratio of those two air densities is 269.6/T_intake by definition. Fitting it gives 0.784; deriving it gives 0.783. A 20 C reference would have given 0.840, which the data excludes -- so the agreement identifies BMW's reference state rather than hiding a knob. Limit to state: k now varies with the pre-throttle intake sensor, which lags under boost; all 22 points are 31-82 kPa where it tracks. Examiners respect a stated scope limit; what they punish is a validation table that implies coverage it does not have.</a:t>
+              <a:t>HONESTY NOTE, say this before an examiner asks. The 1.4% load figure has zero fitted parameters, but it does NOT test the breathing model: manifold pressure is inverted from the same relation, so eta_v cancels. Perturbing eta_v from 0.5 to 1.2 leaves the number at 1.37%. What it DOES pin is the meaning of BMW's relative-filling channel and the engine displacement -- feed it a four-cylinder and it reads 48% instead of 1.4%. The number on this slide is the boosted comparison: the model's manifold pressure against the car's own boost sensor, 3.0% after the charge-temperature correction, 22.6% before it. The normalisation constant k is not tuned: our load is referenced to 100 kPa at the measured intake temperature, BMW's to the DIN state of 1013 mbar and 0 C, and the ratio of those two air densities is 269.6/T_intake by definition. Fitting it gives 0.784; deriving it gives 0.783. A 20 C reference would have given 0.840, which the data excludes -- so the agreement identifies BMW's reference state rather than hiding a knob. Limit to state: k now varies with the pre-throttle intake sensor, which lags under boost; all 22 points are 31-82 kPa where it tracks. Examiners respect a stated scope limit; what they punish is a validation table that implies coverage it does not have.</a:t>
             </a:r>
             <a:endParaRPr lang="en-US" dirty="0"/>
           </a:p>
@@ -3560,7 +3560,7 @@
                 <a:ea typeface="Calibri" pitchFamily="34" charset="-122"/>
                 <a:cs typeface="Calibri" pitchFamily="34" charset="-120"/>
               </a:rPr>
-              <a:t>A 0-D inline-six cycle model, 8 of 11 published quantities inside band and 1.4% load error against the real car, with zero fitted parameters.</a:t>
+              <a:t>A 0-D inline-six cycle model, 8 of 11 published quantities inside band, and a boosted manifold pressure now within 3% of the car's own sensor.</a:t>
             </a:r>
             <a:endParaRPr lang="en-US" sz="1250" dirty="0"/>
           </a:p>
@@ -4793,7 +4793,7 @@
                 <a:ea typeface="Cambria" pitchFamily="34" charset="-122"/>
                 <a:cs typeface="Cambria" pitchFamily="34" charset="-120"/>
               </a:rPr>
-              <a:t>1.4%</a:t>
+              <a:t>3.0%</a:t>
             </a:r>
             <a:endParaRPr lang="en-US" sz="3000" dirty="0"/>
           </a:p>
@@ -4832,7 +4832,7 @@
                 <a:ea typeface="Calibri" pitchFamily="34" charset="-122"/>
                 <a:cs typeface="Calibri" pitchFamily="34" charset="-120"/>
               </a:rPr>
-              <a:t>load error</a:t>
+              <a:t>boost error</a:t>
             </a:r>
             <a:endParaRPr lang="en-US" sz="1350" dirty="0"/>
           </a:p>
@@ -4871,7 +4871,7 @@
                 <a:ea typeface="Calibri" pitchFamily="34" charset="-122"/>
                 <a:cs typeface="Calibri" pitchFamily="34" charset="-120"/>
               </a:rPr>
-              <a:t>zero fitted parameters</a:t>
+              <a:t>vs the car, was 22.6%</a:t>
             </a:r>
             <a:endParaRPr lang="en-US" sz="1150" dirty="0"/>
           </a:p>
@@ -5012,7 +5012,7 @@
                 <a:ea typeface="Calibri" pitchFamily="34" charset="-122"/>
                 <a:cs typeface="Calibri" pitchFamily="34" charset="-120"/>
               </a:rPr>
-              <a:t>Sixty seconds of parked idle proved the channel labelled "manifold pressure" is a pre-throttle sensor. Using it gives 75% error; inverting the air-mass channel gives 1.4% over 22 points.</a:t>
+              <a:t>Sixty seconds of parked idle proved the channel labelled "manifold pressure" is a pre-throttle sensor. Using it gives 75% error; inverting the air-mass channel gives 1.4% over 22 points — a channel-definition check, not a test of the breathing model.</a:t>
             </a:r>
             <a:endParaRPr lang="en-US" sz="1150" dirty="0"/>
           </a:p>

</xml_diff>